<commit_message>
Presentation + demo script updated for live status, new nav and real latency
Deck: 11 slides, adds the GN 167/2016 mantle-size discovery, live gate/benchmark
numbers, deployed URLs. Script: pre-warm + incognito + seed setup, latency
narration budgeted to exactly two model calls, post-redesign navigation.

Co-Authored-By: Claude Fable 5 <noreply@anthropic.com>
</commit_message>
<xml_diff>
--- a/presentation/Lamer_Konekte_5_Minute.pptx
+++ b/presentation/Lamer_Konekte_5_Minute.pptx
@@ -15,6 +15,7 @@
     <p:sldId id="263" r:id="rId14"/>
     <p:sldId id="264" r:id="rId15"/>
     <p:sldId id="265" r:id="rId16"/>
+    <p:sldId id="266" r:id="rId17"/>
   </p:sldIdLst>
   <p:sldSz cx="12191695" cy="6858000" type="screen4x3"/>
   <p:notesSz cx="6858000" cy="9144000"/>
@@ -3242,7 +3243,7 @@
             <a:avLst/>
           </a:prstGeom>
           <a:solidFill>
-            <a:srgbClr val="FF6B57"/>
+            <a:srgbClr val="1B9AAA"/>
           </a:solidFill>
           <a:ln>
             <a:noFill/>
@@ -3295,10 +3296,10 @@
             <a:r>
               <a:rPr sz="1400" b="1">
                 <a:solidFill>
-                  <a:srgbClr val="FF6B57"/>
-                </a:solidFill>
-              </a:rPr>
-              <a:t>4:45 — IMPACT</a:t>
+                  <a:srgbClr val="1B9AAA"/>
+                </a:solidFill>
+              </a:rPr>
+              <a:t>4:20 — MORISYEN</a:t>
             </a:r>
           </a:p>
         </p:txBody>
@@ -3331,7 +3332,7 @@
                   <a:srgbClr val="FAF9F6"/>
                 </a:solidFill>
               </a:rPr>
-              <a:t>From paper to policy-grade data</a:t>
+              <a:t>Morisyen-first, honestly</a:t>
             </a:r>
           </a:p>
         </p:txBody>
@@ -3369,7 +3370,7 @@
                   <a:srgbClr val="DEF2F1"/>
                 </a:solidFill>
               </a:rPr>
-              <a:t>A working preview of digital catch declarations for the Blue Economy</a:t>
+              <a:t>Entire UI in Kreol Morisien and English (~90 strings each)</a:t>
             </a:r>
           </a:p>
           <a:p>
@@ -3384,7 +3385,240 @@
                   <a:srgbClr val="DEF2F1"/>
                 </a:solidFill>
               </a:rPr>
+              <a:t>Every analysis answers in both languages</a:t>
+            </a:r>
+          </a:p>
+          <a:p>
+            <a:pPr>
+              <a:spcAft>
+                <a:spcPts val="1400"/>
+              </a:spcAft>
+            </a:pPr>
+            <a:r>
+              <a:rPr sz="2000">
+                <a:solidFill>
+                  <a:srgbClr val="DEF2F1"/>
+                </a:solidFill>
+              </a:rPr>
+              <a:t>Species names marked provisional until native-speaker review — never guessed silently</a:t>
+            </a:r>
+          </a:p>
+          <a:p>
+            <a:pPr>
+              <a:spcAft>
+                <a:spcPts val="1400"/>
+              </a:spcAft>
+            </a:pPr>
+            <a:r>
+              <a:rPr sz="2000">
+                <a:solidFill>
+                  <a:srgbClr val="DEF2F1"/>
+                </a:solidFill>
+              </a:rPr>
+              <a:t>Licensed dataset: 60 iNaturalist photos, 5 Mauritian species, full attribution</a:t>
+            </a:r>
+          </a:p>
+        </p:txBody>
+      </p:sp>
+    </p:spTree>
+  </p:cSld>
+  <p:clrMapOvr>
+    <a:masterClrMapping/>
+  </p:clrMapOvr>
+</p:sld>
+</file>
+
+<file path=ppt/slides/slide11.xml><?xml version="1.0" encoding="utf-8"?>
+<p:sld xmlns:a="http://schemas.openxmlformats.org/drawingml/2006/main" xmlns:p="http://schemas.openxmlformats.org/presentationml/2006/main" xmlns:r="http://schemas.openxmlformats.org/officeDocument/2006/relationships">
+  <p:cSld>
+    <p:bg>
+      <p:bgPr>
+        <a:solidFill>
+          <a:srgbClr val="0B2545"/>
+        </a:solidFill>
+        <a:effectLst/>
+      </p:bgPr>
+    </p:bg>
+    <p:spTree>
+      <p:nvGrpSpPr>
+        <p:cNvPr id="1" name=""/>
+        <p:cNvGrpSpPr/>
+        <p:nvPr/>
+      </p:nvGrpSpPr>
+      <p:grpSpPr/>
+      <p:sp>
+        <p:nvSpPr>
+          <p:cNvPr id="2" name="Rectangle 1"/>
+          <p:cNvSpPr/>
+          <p:nvPr/>
+        </p:nvSpPr>
+        <p:spPr>
+          <a:xfrm>
+            <a:off x="0" y="0"/>
+            <a:ext cx="12191695" cy="164592"/>
+          </a:xfrm>
+          <a:prstGeom prst="rect">
+            <a:avLst/>
+          </a:prstGeom>
+          <a:solidFill>
+            <a:srgbClr val="FF6B57"/>
+          </a:solidFill>
+          <a:ln>
+            <a:noFill/>
+          </a:ln>
+        </p:spPr>
+        <p:style>
+          <a:lnRef idx="1">
+            <a:schemeClr val="accent1"/>
+          </a:lnRef>
+          <a:fillRef idx="3">
+            <a:schemeClr val="accent1"/>
+          </a:fillRef>
+          <a:effectRef idx="2">
+            <a:schemeClr val="accent1"/>
+          </a:effectRef>
+          <a:fontRef idx="minor">
+            <a:schemeClr val="lt1"/>
+          </a:fontRef>
+        </p:style>
+        <p:txBody>
+          <a:bodyPr rtlCol="0" anchor="ctr"/>
+          <a:lstStyle/>
+          <a:p>
+            <a:pPr algn="ctr"/>
+          </a:p>
+        </p:txBody>
+      </p:sp>
+      <p:sp>
+        <p:nvSpPr>
+          <p:cNvPr id="3" name="TextBox 2"/>
+          <p:cNvSpPr txBox="1"/>
+          <p:nvPr/>
+        </p:nvSpPr>
+        <p:spPr>
+          <a:xfrm>
+            <a:off x="548640" y="411480"/>
+            <a:ext cx="10972800" cy="457200"/>
+          </a:xfrm>
+          <a:prstGeom prst="rect">
+            <a:avLst/>
+          </a:prstGeom>
+          <a:noFill/>
+        </p:spPr>
+        <p:txBody>
+          <a:bodyPr wrap="none">
+            <a:spAutoFit/>
+          </a:bodyPr>
+          <a:lstStyle/>
+          <a:p>
+            <a:r>
+              <a:rPr sz="1400" b="1">
+                <a:solidFill>
+                  <a:srgbClr val="FF6B57"/>
+                </a:solidFill>
+              </a:rPr>
+              <a:t>4:45 — IMPACT</a:t>
+            </a:r>
+          </a:p>
+        </p:txBody>
+      </p:sp>
+      <p:sp>
+        <p:nvSpPr>
+          <p:cNvPr id="4" name="TextBox 3"/>
+          <p:cNvSpPr txBox="1"/>
+          <p:nvPr/>
+        </p:nvSpPr>
+        <p:spPr>
+          <a:xfrm>
+            <a:off x="548640" y="777240"/>
+            <a:ext cx="11064240" cy="1097280"/>
+          </a:xfrm>
+          <a:prstGeom prst="rect">
+            <a:avLst/>
+          </a:prstGeom>
+          <a:noFill/>
+        </p:spPr>
+        <p:txBody>
+          <a:bodyPr wrap="none">
+            <a:spAutoFit/>
+          </a:bodyPr>
+          <a:lstStyle/>
+          <a:p>
+            <a:r>
+              <a:rPr sz="4000" b="1">
+                <a:solidFill>
+                  <a:srgbClr val="FAF9F6"/>
+                </a:solidFill>
+              </a:rPr>
+              <a:t>From paper to policy-grade data</a:t>
+            </a:r>
+          </a:p>
+        </p:txBody>
+      </p:sp>
+      <p:sp>
+        <p:nvSpPr>
+          <p:cNvPr id="5" name="TextBox 4"/>
+          <p:cNvSpPr txBox="1"/>
+          <p:nvPr/>
+        </p:nvSpPr>
+        <p:spPr>
+          <a:xfrm>
+            <a:off x="640080" y="1965960"/>
+            <a:ext cx="10972800" cy="4480560"/>
+          </a:xfrm>
+          <a:prstGeom prst="rect">
+            <a:avLst/>
+          </a:prstGeom>
+          <a:noFill/>
+        </p:spPr>
+        <p:txBody>
+          <a:bodyPr wrap="square">
+            <a:spAutoFit/>
+          </a:bodyPr>
+          <a:lstStyle/>
+          <a:p>
+            <a:pPr>
+              <a:spcAft>
+                <a:spcPts val="1400"/>
+              </a:spcAft>
+            </a:pPr>
+            <a:r>
+              <a:rPr sz="2000">
+                <a:solidFill>
+                  <a:srgbClr val="DEF2F1"/>
+                </a:solidFill>
+              </a:rPr>
+              <a:t>A working preview of digital catch declarations for the Blue Economy</a:t>
+            </a:r>
+          </a:p>
+          <a:p>
+            <a:pPr>
+              <a:spcAft>
+                <a:spcPts val="1400"/>
+              </a:spcAft>
+            </a:pPr>
+            <a:r>
+              <a:rPr sz="2000">
+                <a:solidFill>
+                  <a:srgbClr val="DEF2F1"/>
+                </a:solidFill>
+              </a:rPr>
               <a:t>Humans confirm everything that matters; deterministic code owns the law</a:t>
+            </a:r>
+          </a:p>
+          <a:p>
+            <a:pPr>
+              <a:spcAft>
+                <a:spcPts val="1400"/>
+              </a:spcAft>
+            </a:pPr>
+            <a:r>
+              <a:rPr sz="2000">
+                <a:solidFill>
+                  <a:srgbClr val="DEF2F1"/>
+                </a:solidFill>
+              </a:rPr>
+              <a:t>Live now: lamer-konekte.onrender.com · public Kaggle demo notebook</a:t>
             </a:r>
           </a:p>
           <a:p>
@@ -4053,7 +4287,7 @@
                   <a:srgbClr val="DEF2F1"/>
                 </a:solidFill>
               </a:rPr>
-              <a:t>Gemma family scales down (E2B/E4B) → a credible on-device roadmap for offline lagoons</a:t>
+              <a:t>All 10 hosted gates PASS on real inference — image, Morisyen, tool round trip</a:t>
             </a:r>
           </a:p>
           <a:p>
@@ -4519,7 +4753,7 @@
                   <a:srgbClr val="FF6B57"/>
                 </a:solidFill>
               </a:rPr>
-              <a:t>29 July: no closure · simulated 1 September (badged): closed season, 2016 regulations, ‘provisional’</a:t>
+              <a:t>29 July: no closure · simulated 1 September (badged): closed season, GN 167/2016</a:t>
             </a:r>
           </a:p>
         </p:txBody>
@@ -4565,7 +4799,7 @@
             <a:avLst/>
           </a:prstGeom>
           <a:solidFill>
-            <a:srgbClr val="1B9AAA"/>
+            <a:srgbClr val="FF6B57"/>
           </a:solidFill>
           <a:ln>
             <a:noFill/>
@@ -4618,10 +4852,10 @@
             <a:r>
               <a:rPr sz="1400" b="1">
                 <a:solidFill>
-                  <a:srgbClr val="1B9AAA"/>
-                </a:solidFill>
-              </a:rPr>
-              <a:t>3:10 — LIVE DEMO · LOG &amp; DECLARATION</a:t>
+                  <a:srgbClr val="FF6B57"/>
+                </a:solidFill>
+              </a:rPr>
+              <a:t>THE DETAIL THAT MATTERS</a:t>
             </a:r>
           </a:p>
         </p:txBody>
@@ -4654,7 +4888,7 @@
                   <a:srgbClr val="FAF9F6"/>
                 </a:solidFill>
               </a:rPr>
-              <a:t>Moment 3 — Back ashore</a:t>
+              <a:t>We read the actual law</a:t>
             </a:r>
           </a:p>
         </p:txBody>
@@ -4692,7 +4926,7 @@
                   <a:srgbClr val="DEF2F1"/>
                 </a:solidFill>
               </a:rPr>
-              <a:t>Catch log + today report</a:t>
+              <a:t>GN 167 of 2016 also bans octopus under 7 cm — measured by MANTLE, not total length</a:t>
             </a:r>
           </a:p>
           <a:p>
@@ -4707,7 +4941,7 @@
                   <a:srgbClr val="DEF2F1"/>
                 </a:solidFill>
               </a:rPr>
-              <a:t>Offline-first: IndexedDB queue syncs when connectivity returns</a:t>
+              <a:t>Our app records total length, so a naive check would compare the wrong numbers</a:t>
             </a:r>
           </a:p>
           <a:p>
@@ -4722,7 +4956,7 @@
                   <a:srgbClr val="DEF2F1"/>
                 </a:solidFill>
               </a:rPr>
-              <a:t>Declaration draft → PDF → demonstration receipt</a:t>
+              <a:t>The engine refuses a verdict: returns ‘unknown’ and tells the fisher to measure the mantle</a:t>
             </a:r>
           </a:p>
           <a:p>
@@ -4732,12 +4966,27 @@
               </a:spcAft>
             </a:pPr>
             <a:r>
+              <a:rPr sz="2000">
+                <a:solidFill>
+                  <a:srgbClr val="DEF2F1"/>
+                </a:solidFill>
+              </a:rPr>
+              <a:t>Every rule carries its gazette citation, effective date and verification status</a:t>
+            </a:r>
+          </a:p>
+          <a:p>
+            <a:pPr>
+              <a:spcAft>
+                <a:spcPts val="1400"/>
+              </a:spcAft>
+            </a:pPr>
+            <a:r>
               <a:rPr sz="2000" b="1">
                 <a:solidFill>
                   <a:srgbClr val="FF6B57"/>
                 </a:solidFill>
               </a:rPr>
-              <a:t>Clearly labelled MOCK ministry endpoint — never presented as real government</a:t>
+              <a:t>Unknown over invented — the honest answer is the compliant one</a:t>
             </a:r>
           </a:p>
         </p:txBody>
@@ -4839,7 +5088,7 @@
                   <a:srgbClr val="1B9AAA"/>
                 </a:solidFill>
               </a:rPr>
-              <a:t>3:50 — TECHNICAL PROOF</a:t>
+              <a:t>3:10 — LIVE DEMO · LOG &amp; DECLARATION</a:t>
             </a:r>
           </a:p>
         </p:txBody>
@@ -4872,7 +5121,7 @@
                   <a:srgbClr val="FAF9F6"/>
                 </a:solidFill>
               </a:rPr>
-              <a:t>Engineering proof</a:t>
+              <a:t>Moment 3 — Back ashore</a:t>
             </a:r>
           </a:p>
         </p:txBody>
@@ -4910,7 +5159,7 @@
                   <a:srgbClr val="DEF2F1"/>
                 </a:solidFill>
               </a:rPr>
-              <a:t>12 allow-listed functions · Pydantic-validated · explicit dispatch · redacted traces</a:t>
+              <a:t>Catch log + today report</a:t>
             </a:r>
           </a:p>
           <a:p>
@@ -4925,7 +5174,7 @@
                   <a:srgbClr val="DEF2F1"/>
                 </a:solidFill>
               </a:rPr>
-              <a:t>44 backend tests: rule boundaries, prompt injection, privacy, secret hygiene</a:t>
+              <a:t>Offline-first: IndexedDB queue syncs when connectivity returns</a:t>
             </a:r>
           </a:p>
           <a:p>
@@ -4940,7 +5189,7 @@
                   <a:srgbClr val="DEF2F1"/>
                 </a:solidFill>
               </a:rPr>
-              <a:t>Prototype benchmark: 32 Morisyen cases · 100% schema validity · 0 safety failures</a:t>
+              <a:t>Declaration draft → PDF → demonstration receipt</a:t>
             </a:r>
           </a:p>
           <a:p>
@@ -4950,27 +5199,12 @@
               </a:spcAft>
             </a:pPr>
             <a:r>
-              <a:rPr sz="2000">
-                <a:solidFill>
-                  <a:srgbClr val="DEF2F1"/>
-                </a:solidFill>
-              </a:rPr>
-              <a:t>Training: QLoRA notebooks + leakage-safe data, push-button on Kaggle — status reported honestly</a:t>
-            </a:r>
-          </a:p>
-          <a:p>
-            <a:pPr>
-              <a:spcAft>
-                <a:spcPts val="1400"/>
-              </a:spcAft>
-            </a:pPr>
-            <a:r>
               <a:rPr sz="2000" b="1">
                 <a:solidFill>
                   <a:srgbClr val="FF6B57"/>
                 </a:solidFill>
               </a:rPr>
-              <a:t>Provider badge on every response: hosted / mock / local, with real_inference flag</a:t>
+              <a:t>Clearly labelled MOCK ministry endpoint — never presented as real government</a:t>
             </a:r>
           </a:p>
         </p:txBody>
@@ -5072,7 +5306,7 @@
                   <a:srgbClr val="1B9AAA"/>
                 </a:solidFill>
               </a:rPr>
-              <a:t>4:20 — MORISYEN</a:t>
+              <a:t>3:50 — TECHNICAL PROOF</a:t>
             </a:r>
           </a:p>
         </p:txBody>
@@ -5105,7 +5339,7 @@
                   <a:srgbClr val="FAF9F6"/>
                 </a:solidFill>
               </a:rPr>
-              <a:t>Morisyen-first, honestly</a:t>
+              <a:t>Engineering proof</a:t>
             </a:r>
           </a:p>
         </p:txBody>
@@ -5143,7 +5377,7 @@
                   <a:srgbClr val="DEF2F1"/>
                 </a:solidFill>
               </a:rPr>
-              <a:t>Entire UI in Kreol Morisien and English (~90 strings each)</a:t>
+              <a:t>12 allow-listed functions · Pydantic-validated · explicit dispatch · redacted traces</a:t>
             </a:r>
           </a:p>
           <a:p>
@@ -5158,7 +5392,7 @@
                   <a:srgbClr val="DEF2F1"/>
                 </a:solidFill>
               </a:rPr>
-              <a:t>Every analysis answers in both languages</a:t>
+              <a:t>100 backend tests: rule boundaries, prompt injection, privacy, secret hygiene</a:t>
             </a:r>
           </a:p>
           <a:p>
@@ -5173,7 +5407,7 @@
                   <a:srgbClr val="DEF2F1"/>
                 </a:solidFill>
               </a:rPr>
-              <a:t>Species names marked provisional until native-speaker review — never guessed silently</a:t>
+              <a:t>Live benchmark: 96.9% Morisyen intent · 100% schema validity · 0 safety failures</a:t>
             </a:r>
           </a:p>
           <a:p>
@@ -5188,7 +5422,22 @@
                   <a:srgbClr val="DEF2F1"/>
                 </a:solidFill>
               </a:rPr>
-              <a:t>Licensed dataset: 60 iNaturalist photos, 5 Mauritian species, full attribution</a:t>
+              <a:t>Deployed public PWA + public Kaggle notebook, both on real Gemma inference</a:t>
+            </a:r>
+          </a:p>
+          <a:p>
+            <a:pPr>
+              <a:spcAft>
+                <a:spcPts val="1400"/>
+              </a:spcAft>
+            </a:pPr>
+            <a:r>
+              <a:rPr sz="2000" b="1">
+                <a:solidFill>
+                  <a:srgbClr val="FF6B57"/>
+                </a:solidFill>
+              </a:rPr>
+              <a:t>Provider badge on every response: hosted / mock / local, with real_inference flag</a:t>
             </a:r>
           </a:p>
         </p:txBody>

</xml_diff>